<commit_message>
Explainable notebook: worked MQAR example (table, two anchors for y_8, B=1 shapes, alignment and causality checks, trained-checkpoint modes); exact source of the example in deck and text
The deck example [54, 76, 8, 96, ...] is the generator with seed derive_seed(901, 0) and a batch of 1, not sequence 0 of the
1024-sequence evaluation set; captions corrected.

Co-Authored-By: Claude Opus 5.5 <noreply@anthropic.com>
</commit_message>
<xml_diff>
--- a/deck/SMT_MemUP_2026-10-26.pptx
+++ b/deck/SMT_MemUP_2026-10-26.pptx
@@ -3361,7 +3361,7 @@
                           </a:solidFill>
                           <a:latin typeface="Arial"/>
                         </a:rPr>
-                        <a:t>полный BPTT той же RNN: 99,6% (99,3 / 99,9 / 99,5); BPTT-1: 31,2 / — / —</a:t>
+                        <a:t>полный BPTT той же RNN: 99,6% (99,3 / 99,9 / 99,5); BPTT-1: 31,2 / 30,6 / —</a:t>
                       </a:r>
                     </a:p>
                   </a:txBody>
@@ -3484,7 +3484,7 @@
                           </a:solidFill>
                           <a:latin typeface="Arial"/>
                         </a:rPr>
-                        <a:t>при длинном бюджете: 55,7 / 99,3 / — (seed 203 идёт)</a:t>
+                        <a:t>при длинном бюджете: 55,7 / 99,3 / 97,8 (seed 203 идёт)</a:t>
                       </a:r>
                     </a:p>
                   </a:txBody>
@@ -4261,7 +4261,7 @@
                 </a:solidFill>
                 <a:latin typeface="Arial"/>
               </a:rPr>
-              <a:t>Пример T = 16, N = 2 (поток 901, последовательность 0; ноутбук §2.2)</a:t>
+              <a:t>Пример T = 16, N = 2: генератор, seed derive_seed(901, 0), одна последовательность (ноутбук §2.3, §8.1)</a:t>
             </a:r>
           </a:p>
         </p:txBody>
@@ -7627,7 +7627,7 @@
         <p:spPr>
           <a:xfrm>
             <a:off x="457200" y="1143000"/>
-            <a:ext cx="9082216" cy="4800600"/>
+            <a:ext cx="7814930" cy="4800600"/>
           </a:xfrm>
           <a:prstGeom prst="rect">
             <a:avLst/>
@@ -7764,7 +7764,7 @@
                 </a:solidFill>
                 <a:latin typeface="Arial"/>
               </a:rPr>
-              <a:t>39,9 / 44,9 / 50,9 / 55,7 / 99,3 / —</a:t>
+              <a:t>39,9 / 44,9 / 50,9 / 55,7 / 99,3 / 97,8</a:t>
             </a:r>
           </a:p>
           <a:p>
@@ -8946,7 +8946,7 @@
                           </a:solidFill>
                           <a:latin typeface="Arial"/>
                         </a:rPr>
-                        <a:t>Итоговая RNN после DMT ниже teacher (57,6%). Полный BPTT с бюджетом до 60k: 55,7 / 99,3 / —. T = 32: teacher нестабилен по seeds.</a:t>
+                        <a:t>Итоговая RNN после DMT ниже teacher (57,6%). Полный BPTT с бюджетом до 60k: 55,7 / 99,3 / 97,8. T = 32: teacher нестабилен по seeds.</a:t>
                       </a:r>
                     </a:p>
                   </a:txBody>
@@ -9189,7 +9189,7 @@
                           </a:solidFill>
                           <a:latin typeface="Arial"/>
                         </a:rPr>
-                        <a:t>6 000 шагов не хватило; до 60 000: 55,7 / 99,3 / —; учится, но не на каждом seed</a:t>
+                        <a:t>6 000 шагов не хватило; до 60 000: 55,7 / 99,3 / 97,8; учится, но не на каждом seed</a:t>
                       </a:r>
                     </a:p>
                   </a:txBody>
@@ -12179,7 +12179,7 @@
         <p:spPr>
           <a:xfrm>
             <a:off x="822960" y="1143000"/>
-            <a:ext cx="9341708" cy="4937760"/>
+            <a:ext cx="8038213" cy="4937760"/>
           </a:xfrm>
           <a:prstGeom prst="rect">
             <a:avLst/>
@@ -16571,7 +16571,7 @@
                           </a:solidFill>
                           <a:latin typeface="Arial"/>
                         </a:rPr>
-                        <a:t>31,2 / — / —</a:t>
+                        <a:t>31,2 / 30,6 / —</a:t>
                       </a:r>
                     </a:p>
                   </a:txBody>

</xml_diff>